<commit_message>
Config de API keys persistente + despliegue Docker
- kobra/config.py: guarda OPENAI_API_KEY / ANTHROPIC_API_KEY una sola vez
  ($KOBRA_CONFIG_DIR/config.json) y las carga solas en cada arranque; el
  entorno tiene prioridad. Pestaña "Configuración" en el dashboard (ingresar,
  guardar, borrar, estado enmascarado). El realtime también las aplica.
- Docker: Dockerfile (imagen única) + docker-compose (dashboard 8501 + realtime
  8000) + docker-entrypoint (autogenera datos/modelo) + .dockerignore.
  Volúmenes persisten config, datos y outputs. Compose validado.
- Tests de persistencia de config (15 en total). Deck a 18 slides
  (slide "Listo para producción").
- README: secciones de despliegue Docker y configuración de keys.

Co-Authored-By: Claude Opus 4.8 <noreply@anthropic.com>
Claude-Session: https://claude.ai/code/session_01KGnVQvVgKrpMBAH6ciJfTu
</commit_message>
<xml_diff>
--- a/presentation/Kobra_Presentacion_Gerencial.pptx
+++ b/presentation/Kobra_Presentacion_Gerencial.pptx
@@ -22,6 +22,7 @@
     <p:sldId id="270" r:id="rId21"/>
     <p:sldId id="271" r:id="rId22"/>
     <p:sldId id="272" r:id="rId23"/>
+    <p:sldId id="273" r:id="rId24"/>
   </p:sldIdLst>
   <p:sldSz cx="12191695" cy="6858000" type="screen4x3"/>
   <p:notesSz cx="6858000" cy="9144000"/>
@@ -4905,6 +4906,691 @@
 </file>
 
 <file path=ppt/slides/slide17.xml><?xml version="1.0" encoding="utf-8"?>
+<p:sld xmlns:a="http://schemas.openxmlformats.org/drawingml/2006/main" xmlns:p="http://schemas.openxmlformats.org/presentationml/2006/main" xmlns:r="http://schemas.openxmlformats.org/officeDocument/2006/relationships">
+  <p:cSld>
+    <p:bg>
+      <p:bgPr>
+        <a:solidFill>
+          <a:srgbClr val="0E1117"/>
+        </a:solidFill>
+        <a:effectLst/>
+      </p:bgPr>
+    </p:bg>
+    <p:spTree>
+      <p:nvGrpSpPr>
+        <p:cNvPr id="1" name=""/>
+        <p:cNvGrpSpPr/>
+        <p:nvPr/>
+      </p:nvGrpSpPr>
+      <p:grpSpPr/>
+      <p:sp>
+        <p:nvSpPr>
+          <p:cNvPr id="2" name="TextBox 1"/>
+          <p:cNvSpPr txBox="1"/>
+          <p:nvPr/>
+        </p:nvSpPr>
+        <p:spPr>
+          <a:xfrm>
+            <a:off x="640080" y="457200"/>
+            <a:ext cx="10972800" cy="731520"/>
+          </a:xfrm>
+          <a:prstGeom prst="rect">
+            <a:avLst/>
+          </a:prstGeom>
+          <a:noFill/>
+        </p:spPr>
+        <p:txBody>
+          <a:bodyPr wrap="square" anchor="t">
+            <a:spAutoFit/>
+          </a:bodyPr>
+          <a:lstStyle/>
+          <a:p>
+            <a:pPr algn="l"/>
+            <a:r>
+              <a:rPr sz="3200" b="1">
+                <a:solidFill>
+                  <a:srgbClr val="F5F6FA"/>
+                </a:solidFill>
+                <a:latin typeface="Segoe UI"/>
+              </a:rPr>
+              <a:t>Listo para producción</a:t>
+            </a:r>
+          </a:p>
+        </p:txBody>
+      </p:sp>
+      <p:sp>
+        <p:nvSpPr>
+          <p:cNvPr id="3" name="Rounded Rectangle 2"/>
+          <p:cNvSpPr/>
+          <p:nvPr/>
+        </p:nvSpPr>
+        <p:spPr>
+          <a:xfrm>
+            <a:off x="640080" y="1280160"/>
+            <a:ext cx="137160" cy="640080"/>
+          </a:xfrm>
+          <a:prstGeom prst="roundRect">
+            <a:avLst/>
+          </a:prstGeom>
+          <a:solidFill>
+            <a:srgbClr val="00C896"/>
+          </a:solidFill>
+          <a:ln>
+            <a:noFill/>
+          </a:ln>
+          <a:effectLst/>
+        </p:spPr>
+        <p:style>
+          <a:lnRef idx="1">
+            <a:schemeClr val="accent1"/>
+          </a:lnRef>
+          <a:fillRef idx="3">
+            <a:schemeClr val="accent1"/>
+          </a:fillRef>
+          <a:effectRef idx="2">
+            <a:schemeClr val="accent1"/>
+          </a:effectRef>
+          <a:fontRef idx="minor">
+            <a:schemeClr val="lt1"/>
+          </a:fontRef>
+        </p:style>
+        <p:txBody>
+          <a:bodyPr rtlCol="0" anchor="ctr"/>
+          <a:lstStyle/>
+          <a:p>
+            <a:pPr algn="ctr"/>
+          </a:p>
+        </p:txBody>
+      </p:sp>
+      <p:sp>
+        <p:nvSpPr>
+          <p:cNvPr id="4" name="Rounded Rectangle 3"/>
+          <p:cNvSpPr/>
+          <p:nvPr/>
+        </p:nvSpPr>
+        <p:spPr>
+          <a:xfrm>
+            <a:off x="822960" y="1828800"/>
+            <a:ext cx="4206240" cy="786384"/>
+          </a:xfrm>
+          <a:prstGeom prst="roundRect">
+            <a:avLst/>
+          </a:prstGeom>
+          <a:solidFill>
+            <a:srgbClr val="1A1F2E"/>
+          </a:solidFill>
+          <a:ln w="12700">
+            <a:solidFill>
+              <a:srgbClr val="00C896"/>
+            </a:solidFill>
+          </a:ln>
+          <a:effectLst/>
+        </p:spPr>
+        <p:style>
+          <a:lnRef idx="1">
+            <a:schemeClr val="accent1"/>
+          </a:lnRef>
+          <a:fillRef idx="3">
+            <a:schemeClr val="accent1"/>
+          </a:fillRef>
+          <a:effectRef idx="2">
+            <a:schemeClr val="accent1"/>
+          </a:effectRef>
+          <a:fontRef idx="minor">
+            <a:schemeClr val="lt1"/>
+          </a:fontRef>
+        </p:style>
+        <p:txBody>
+          <a:bodyPr rtlCol="0" anchor="ctr"/>
+          <a:lstStyle/>
+          <a:p>
+            <a:pPr algn="ctr"/>
+          </a:p>
+        </p:txBody>
+      </p:sp>
+      <p:sp>
+        <p:nvSpPr>
+          <p:cNvPr id="5" name="TextBox 4"/>
+          <p:cNvSpPr txBox="1"/>
+          <p:nvPr/>
+        </p:nvSpPr>
+        <p:spPr>
+          <a:xfrm>
+            <a:off x="1005840" y="1975104"/>
+            <a:ext cx="3931920" cy="548640"/>
+          </a:xfrm>
+          <a:prstGeom prst="rect">
+            <a:avLst/>
+          </a:prstGeom>
+          <a:noFill/>
+        </p:spPr>
+        <p:txBody>
+          <a:bodyPr wrap="square" anchor="t">
+            <a:spAutoFit/>
+          </a:bodyPr>
+          <a:lstStyle/>
+          <a:p>
+            <a:pPr algn="l"/>
+            <a:r>
+              <a:rPr sz="1500" b="1">
+                <a:solidFill>
+                  <a:srgbClr val="00C896"/>
+                </a:solidFill>
+                <a:latin typeface="Segoe UI"/>
+              </a:rPr>
+              <a:t>🐳 Despliegue en 1 comando</a:t>
+            </a:r>
+          </a:p>
+        </p:txBody>
+      </p:sp>
+      <p:sp>
+        <p:nvSpPr>
+          <p:cNvPr id="6" name="TextBox 5"/>
+          <p:cNvSpPr txBox="1"/>
+          <p:nvPr/>
+        </p:nvSpPr>
+        <p:spPr>
+          <a:xfrm>
+            <a:off x="5303520" y="1920240"/>
+            <a:ext cx="6217920" cy="640080"/>
+          </a:xfrm>
+          <a:prstGeom prst="rect">
+            <a:avLst/>
+          </a:prstGeom>
+          <a:noFill/>
+        </p:spPr>
+        <p:txBody>
+          <a:bodyPr wrap="square" anchor="t">
+            <a:spAutoFit/>
+          </a:bodyPr>
+          <a:lstStyle/>
+          <a:p>
+            <a:pPr algn="l"/>
+            <a:r>
+              <a:rPr sz="1400" b="0">
+                <a:solidFill>
+                  <a:srgbClr val="F5F6FA"/>
+                </a:solidFill>
+                <a:latin typeface="Segoe UI"/>
+              </a:rPr>
+              <a:t>docker compose up: dashboard + servicio de audio en vivo, con datos y modelo autogenerados.</a:t>
+            </a:r>
+          </a:p>
+        </p:txBody>
+      </p:sp>
+      <p:sp>
+        <p:nvSpPr>
+          <p:cNvPr id="7" name="Rounded Rectangle 6"/>
+          <p:cNvSpPr/>
+          <p:nvPr/>
+        </p:nvSpPr>
+        <p:spPr>
+          <a:xfrm>
+            <a:off x="822960" y="2724912"/>
+            <a:ext cx="4206240" cy="786384"/>
+          </a:xfrm>
+          <a:prstGeom prst="roundRect">
+            <a:avLst/>
+          </a:prstGeom>
+          <a:solidFill>
+            <a:srgbClr val="1A1F2E"/>
+          </a:solidFill>
+          <a:ln w="12700">
+            <a:solidFill>
+              <a:srgbClr val="00C896"/>
+            </a:solidFill>
+          </a:ln>
+          <a:effectLst/>
+        </p:spPr>
+        <p:style>
+          <a:lnRef idx="1">
+            <a:schemeClr val="accent1"/>
+          </a:lnRef>
+          <a:fillRef idx="3">
+            <a:schemeClr val="accent1"/>
+          </a:fillRef>
+          <a:effectRef idx="2">
+            <a:schemeClr val="accent1"/>
+          </a:effectRef>
+          <a:fontRef idx="minor">
+            <a:schemeClr val="lt1"/>
+          </a:fontRef>
+        </p:style>
+        <p:txBody>
+          <a:bodyPr rtlCol="0" anchor="ctr"/>
+          <a:lstStyle/>
+          <a:p>
+            <a:pPr algn="ctr"/>
+          </a:p>
+        </p:txBody>
+      </p:sp>
+      <p:sp>
+        <p:nvSpPr>
+          <p:cNvPr id="8" name="TextBox 7"/>
+          <p:cNvSpPr txBox="1"/>
+          <p:nvPr/>
+        </p:nvSpPr>
+        <p:spPr>
+          <a:xfrm>
+            <a:off x="1005840" y="2871216"/>
+            <a:ext cx="3931920" cy="548640"/>
+          </a:xfrm>
+          <a:prstGeom prst="rect">
+            <a:avLst/>
+          </a:prstGeom>
+          <a:noFill/>
+        </p:spPr>
+        <p:txBody>
+          <a:bodyPr wrap="square" anchor="t">
+            <a:spAutoFit/>
+          </a:bodyPr>
+          <a:lstStyle/>
+          <a:p>
+            <a:pPr algn="l"/>
+            <a:r>
+              <a:rPr sz="1500" b="1">
+                <a:solidFill>
+                  <a:srgbClr val="00C896"/>
+                </a:solidFill>
+                <a:latin typeface="Segoe UI"/>
+              </a:rPr>
+              <a:t>🔑 API keys persistentes</a:t>
+            </a:r>
+          </a:p>
+        </p:txBody>
+      </p:sp>
+      <p:sp>
+        <p:nvSpPr>
+          <p:cNvPr id="9" name="TextBox 8"/>
+          <p:cNvSpPr txBox="1"/>
+          <p:nvPr/>
+        </p:nvSpPr>
+        <p:spPr>
+          <a:xfrm>
+            <a:off x="5303520" y="2816352"/>
+            <a:ext cx="6217920" cy="640080"/>
+          </a:xfrm>
+          <a:prstGeom prst="rect">
+            <a:avLst/>
+          </a:prstGeom>
+          <a:noFill/>
+        </p:spPr>
+        <p:txBody>
+          <a:bodyPr wrap="square" anchor="t">
+            <a:spAutoFit/>
+          </a:bodyPr>
+          <a:lstStyle/>
+          <a:p>
+            <a:pPr algn="l"/>
+            <a:r>
+              <a:rPr sz="1400" b="0">
+                <a:solidFill>
+                  <a:srgbClr val="F5F6FA"/>
+                </a:solidFill>
+                <a:latin typeface="Segoe UI"/>
+              </a:rPr>
+              <a:t>Se cargan una vez desde la pestaña Configuración (o por variables de entorno) y quedan guardadas.</a:t>
+            </a:r>
+          </a:p>
+        </p:txBody>
+      </p:sp>
+      <p:sp>
+        <p:nvSpPr>
+          <p:cNvPr id="10" name="Rounded Rectangle 9"/>
+          <p:cNvSpPr/>
+          <p:nvPr/>
+        </p:nvSpPr>
+        <p:spPr>
+          <a:xfrm>
+            <a:off x="822960" y="3621024"/>
+            <a:ext cx="4206240" cy="786384"/>
+          </a:xfrm>
+          <a:prstGeom prst="roundRect">
+            <a:avLst/>
+          </a:prstGeom>
+          <a:solidFill>
+            <a:srgbClr val="1A1F2E"/>
+          </a:solidFill>
+          <a:ln w="12700">
+            <a:solidFill>
+              <a:srgbClr val="00C896"/>
+            </a:solidFill>
+          </a:ln>
+          <a:effectLst/>
+        </p:spPr>
+        <p:style>
+          <a:lnRef idx="1">
+            <a:schemeClr val="accent1"/>
+          </a:lnRef>
+          <a:fillRef idx="3">
+            <a:schemeClr val="accent1"/>
+          </a:fillRef>
+          <a:effectRef idx="2">
+            <a:schemeClr val="accent1"/>
+          </a:effectRef>
+          <a:fontRef idx="minor">
+            <a:schemeClr val="lt1"/>
+          </a:fontRef>
+        </p:style>
+        <p:txBody>
+          <a:bodyPr rtlCol="0" anchor="ctr"/>
+          <a:lstStyle/>
+          <a:p>
+            <a:pPr algn="ctr"/>
+          </a:p>
+        </p:txBody>
+      </p:sp>
+      <p:sp>
+        <p:nvSpPr>
+          <p:cNvPr id="11" name="TextBox 10"/>
+          <p:cNvSpPr txBox="1"/>
+          <p:nvPr/>
+        </p:nvSpPr>
+        <p:spPr>
+          <a:xfrm>
+            <a:off x="1005840" y="3767328"/>
+            <a:ext cx="3931920" cy="548640"/>
+          </a:xfrm>
+          <a:prstGeom prst="rect">
+            <a:avLst/>
+          </a:prstGeom>
+          <a:noFill/>
+        </p:spPr>
+        <p:txBody>
+          <a:bodyPr wrap="square" anchor="t">
+            <a:spAutoFit/>
+          </a:bodyPr>
+          <a:lstStyle/>
+          <a:p>
+            <a:pPr algn="l"/>
+            <a:r>
+              <a:rPr sz="1500" b="1">
+                <a:solidFill>
+                  <a:srgbClr val="00C896"/>
+                </a:solidFill>
+                <a:latin typeface="Segoe UI"/>
+              </a:rPr>
+              <a:t>☎️ Integración telefónica</a:t>
+            </a:r>
+          </a:p>
+        </p:txBody>
+      </p:sp>
+      <p:sp>
+        <p:nvSpPr>
+          <p:cNvPr id="12" name="TextBox 11"/>
+          <p:cNvSpPr txBox="1"/>
+          <p:nvPr/>
+        </p:nvSpPr>
+        <p:spPr>
+          <a:xfrm>
+            <a:off x="5303520" y="3712464"/>
+            <a:ext cx="6217920" cy="640080"/>
+          </a:xfrm>
+          <a:prstGeom prst="rect">
+            <a:avLst/>
+          </a:prstGeom>
+          <a:noFill/>
+        </p:spPr>
+        <p:txBody>
+          <a:bodyPr wrap="square" anchor="t">
+            <a:spAutoFit/>
+          </a:bodyPr>
+          <a:lstStyle/>
+          <a:p>
+            <a:pPr algn="l"/>
+            <a:r>
+              <a:rPr sz="1400" b="0">
+                <a:solidFill>
+                  <a:srgbClr val="F5F6FA"/>
+                </a:solidFill>
+                <a:latin typeface="Segoe UI"/>
+              </a:rPr>
+              <a:t>Conectores para Avaya/Genesys/Twilio (SIPREC · Media Streams · DMCC) — grabación o streaming en vivo.</a:t>
+            </a:r>
+          </a:p>
+        </p:txBody>
+      </p:sp>
+      <p:sp>
+        <p:nvSpPr>
+          <p:cNvPr id="13" name="Rounded Rectangle 12"/>
+          <p:cNvSpPr/>
+          <p:nvPr/>
+        </p:nvSpPr>
+        <p:spPr>
+          <a:xfrm>
+            <a:off x="822960" y="4517136"/>
+            <a:ext cx="4206240" cy="786384"/>
+          </a:xfrm>
+          <a:prstGeom prst="roundRect">
+            <a:avLst/>
+          </a:prstGeom>
+          <a:solidFill>
+            <a:srgbClr val="1A1F2E"/>
+          </a:solidFill>
+          <a:ln w="12700">
+            <a:solidFill>
+              <a:srgbClr val="00C896"/>
+            </a:solidFill>
+          </a:ln>
+          <a:effectLst/>
+        </p:spPr>
+        <p:style>
+          <a:lnRef idx="1">
+            <a:schemeClr val="accent1"/>
+          </a:lnRef>
+          <a:fillRef idx="3">
+            <a:schemeClr val="accent1"/>
+          </a:fillRef>
+          <a:effectRef idx="2">
+            <a:schemeClr val="accent1"/>
+          </a:effectRef>
+          <a:fontRef idx="minor">
+            <a:schemeClr val="lt1"/>
+          </a:fontRef>
+        </p:style>
+        <p:txBody>
+          <a:bodyPr rtlCol="0" anchor="ctr"/>
+          <a:lstStyle/>
+          <a:p>
+            <a:pPr algn="ctr"/>
+          </a:p>
+        </p:txBody>
+      </p:sp>
+      <p:sp>
+        <p:nvSpPr>
+          <p:cNvPr id="14" name="TextBox 13"/>
+          <p:cNvSpPr txBox="1"/>
+          <p:nvPr/>
+        </p:nvSpPr>
+        <p:spPr>
+          <a:xfrm>
+            <a:off x="1005840" y="4663440"/>
+            <a:ext cx="3931920" cy="548640"/>
+          </a:xfrm>
+          <a:prstGeom prst="rect">
+            <a:avLst/>
+          </a:prstGeom>
+          <a:noFill/>
+        </p:spPr>
+        <p:txBody>
+          <a:bodyPr wrap="square" anchor="t">
+            <a:spAutoFit/>
+          </a:bodyPr>
+          <a:lstStyle/>
+          <a:p>
+            <a:pPr algn="l"/>
+            <a:r>
+              <a:rPr sz="1500" b="1">
+                <a:solidFill>
+                  <a:srgbClr val="00C896"/>
+                </a:solidFill>
+                <a:latin typeface="Segoe UI"/>
+              </a:rPr>
+              <a:t>✅ Calidad asegurada</a:t>
+            </a:r>
+          </a:p>
+        </p:txBody>
+      </p:sp>
+      <p:sp>
+        <p:nvSpPr>
+          <p:cNvPr id="15" name="TextBox 14"/>
+          <p:cNvSpPr txBox="1"/>
+          <p:nvPr/>
+        </p:nvSpPr>
+        <p:spPr>
+          <a:xfrm>
+            <a:off x="5303520" y="4608576"/>
+            <a:ext cx="6217920" cy="640080"/>
+          </a:xfrm>
+          <a:prstGeom prst="rect">
+            <a:avLst/>
+          </a:prstGeom>
+          <a:noFill/>
+        </p:spPr>
+        <p:txBody>
+          <a:bodyPr wrap="square" anchor="t">
+            <a:spAutoFit/>
+          </a:bodyPr>
+          <a:lstStyle/>
+          <a:p>
+            <a:pPr algn="l"/>
+            <a:r>
+              <a:rPr sz="1400" b="0">
+                <a:solidFill>
+                  <a:srgbClr val="F5F6FA"/>
+                </a:solidFill>
+                <a:latin typeface="Segoe UI"/>
+              </a:rPr>
+              <a:t>Suite de tests + CI (GitHub Actions) y reentrenamiento programado del modelo ProbPago.</a:t>
+            </a:r>
+          </a:p>
+        </p:txBody>
+      </p:sp>
+      <p:sp>
+        <p:nvSpPr>
+          <p:cNvPr id="16" name="Rounded Rectangle 15"/>
+          <p:cNvSpPr/>
+          <p:nvPr/>
+        </p:nvSpPr>
+        <p:spPr>
+          <a:xfrm>
+            <a:off x="822960" y="5413248"/>
+            <a:ext cx="4206240" cy="786384"/>
+          </a:xfrm>
+          <a:prstGeom prst="roundRect">
+            <a:avLst/>
+          </a:prstGeom>
+          <a:solidFill>
+            <a:srgbClr val="1A1F2E"/>
+          </a:solidFill>
+          <a:ln w="12700">
+            <a:solidFill>
+              <a:srgbClr val="00C896"/>
+            </a:solidFill>
+          </a:ln>
+          <a:effectLst/>
+        </p:spPr>
+        <p:style>
+          <a:lnRef idx="1">
+            <a:schemeClr val="accent1"/>
+          </a:lnRef>
+          <a:fillRef idx="3">
+            <a:schemeClr val="accent1"/>
+          </a:fillRef>
+          <a:effectRef idx="2">
+            <a:schemeClr val="accent1"/>
+          </a:effectRef>
+          <a:fontRef idx="minor">
+            <a:schemeClr val="lt1"/>
+          </a:fontRef>
+        </p:style>
+        <p:txBody>
+          <a:bodyPr rtlCol="0" anchor="ctr"/>
+          <a:lstStyle/>
+          <a:p>
+            <a:pPr algn="ctr"/>
+          </a:p>
+        </p:txBody>
+      </p:sp>
+      <p:sp>
+        <p:nvSpPr>
+          <p:cNvPr id="17" name="TextBox 16"/>
+          <p:cNvSpPr txBox="1"/>
+          <p:nvPr/>
+        </p:nvSpPr>
+        <p:spPr>
+          <a:xfrm>
+            <a:off x="1005840" y="5559552"/>
+            <a:ext cx="3931920" cy="548640"/>
+          </a:xfrm>
+          <a:prstGeom prst="rect">
+            <a:avLst/>
+          </a:prstGeom>
+          <a:noFill/>
+        </p:spPr>
+        <p:txBody>
+          <a:bodyPr wrap="square" anchor="t">
+            <a:spAutoFit/>
+          </a:bodyPr>
+          <a:lstStyle/>
+          <a:p>
+            <a:pPr algn="l"/>
+            <a:r>
+              <a:rPr sz="1500" b="1">
+                <a:solidFill>
+                  <a:srgbClr val="00C896"/>
+                </a:solidFill>
+                <a:latin typeface="Segoe UI"/>
+              </a:rPr>
+              <a:t>🔒 Sin datos sensibles</a:t>
+            </a:r>
+          </a:p>
+        </p:txBody>
+      </p:sp>
+      <p:sp>
+        <p:nvSpPr>
+          <p:cNvPr id="18" name="TextBox 17"/>
+          <p:cNvSpPr txBox="1"/>
+          <p:nvPr/>
+        </p:nvSpPr>
+        <p:spPr>
+          <a:xfrm>
+            <a:off x="5303520" y="5504688"/>
+            <a:ext cx="6217920" cy="640080"/>
+          </a:xfrm>
+          <a:prstGeom prst="rect">
+            <a:avLst/>
+          </a:prstGeom>
+          <a:noFill/>
+        </p:spPr>
+        <p:txBody>
+          <a:bodyPr wrap="square" anchor="t">
+            <a:spAutoFit/>
+          </a:bodyPr>
+          <a:lstStyle/>
+          <a:p>
+            <a:pPr algn="l"/>
+            <a:r>
+              <a:rPr sz="1400" b="0">
+                <a:solidFill>
+                  <a:srgbClr val="F5F6FA"/>
+                </a:solidFill>
+                <a:latin typeface="Segoe UI"/>
+              </a:rPr>
+              <a:t>Dataset sintético, sin nombres de clientes. Reemplazable por la cartera real de la empresa.</a:t>
+            </a:r>
+          </a:p>
+        </p:txBody>
+      </p:sp>
+    </p:spTree>
+  </p:cSld>
+  <p:clrMapOvr>
+    <a:masterClrMapping/>
+  </p:clrMapOvr>
+</p:sld>
+</file>
+
+<file path=ppt/slides/slide18.xml><?xml version="1.0" encoding="utf-8"?>
 <p:sld xmlns:a="http://schemas.openxmlformats.org/drawingml/2006/main" xmlns:p="http://schemas.openxmlformats.org/presentationml/2006/main" xmlns:r="http://schemas.openxmlformats.org/officeDocument/2006/relationships">
   <p:cSld>
     <p:bg>

</xml_diff>

<commit_message>
Ciclo CTI, honestidad de números, marca, releases y demo pública
Briefing pre-llamada + registro post-llamada (ciclo completo con la central telefónica); reetiquetado honesto de métricas sintéticas (README/dashboard/PPT); identidad de marca (logo/ícono/video demo); empaquetador de ZIP Demo y Producción con compatibilidad Windows (decoder μ-law sin audioop, BOM/CRLF); config de Vercel para publicar el dashboard estático.
</commit_message>
<xml_diff>
--- a/presentation/Kobra_Presentacion_Gerencial.pptx
+++ b/presentation/Kobra_Presentacion_Gerencial.pptx
@@ -3155,9 +3155,33 @@
           </a:p>
         </p:txBody>
       </p:sp>
-      <p:sp>
-        <p:nvSpPr>
-          <p:cNvPr id="3" name="TextBox 2"/>
+      <p:pic>
+        <p:nvPicPr>
+          <p:cNvPr id="3" name="Picture 2" descr="kobra_icon.png"/>
+          <p:cNvPicPr>
+            <a:picLocks noChangeAspect="1"/>
+          </p:cNvPicPr>
+          <p:nvPr/>
+        </p:nvPicPr>
+        <p:blipFill>
+          <a:blip r:embed="rId2"/>
+          <a:stretch>
+            <a:fillRect/>
+          </a:stretch>
+        </p:blipFill>
+        <p:spPr>
+          <a:xfrm>
+            <a:off x="5413248" y="777240"/>
+            <a:ext cx="1371600" cy="1371600"/>
+          </a:xfrm>
+          <a:prstGeom prst="rect">
+            <a:avLst/>
+          </a:prstGeom>
+        </p:spPr>
+      </p:pic>
+      <p:sp>
+        <p:nvSpPr>
+          <p:cNvPr id="4" name="TextBox 3"/>
           <p:cNvSpPr txBox="1"/>
           <p:nvPr/>
         </p:nvSpPr>
@@ -3185,14 +3209,14 @@
                 </a:solidFill>
                 <a:latin typeface="Segoe UI"/>
               </a:rPr>
-              <a:t>🐍 Kobra</a:t>
-            </a:r>
-          </a:p>
-        </p:txBody>
-      </p:sp>
-      <p:sp>
-        <p:nvSpPr>
-          <p:cNvPr id="4" name="TextBox 3"/>
+              <a:t>Kobra</a:t>
+            </a:r>
+          </a:p>
+        </p:txBody>
+      </p:sp>
+      <p:sp>
+        <p:nvSpPr>
+          <p:cNvPr id="5" name="TextBox 4"/>
           <p:cNvSpPr txBox="1"/>
           <p:nvPr/>
         </p:nvSpPr>
@@ -3227,7 +3251,7 @@
       </p:sp>
       <p:sp>
         <p:nvSpPr>
-          <p:cNvPr id="5" name="TextBox 4"/>
+          <p:cNvPr id="6" name="TextBox 5"/>
           <p:cNvSpPr txBox="1"/>
           <p:nvPr/>
         </p:nvSpPr>
@@ -3262,7 +3286,7 @@
       </p:sp>
       <p:sp>
         <p:nvSpPr>
-          <p:cNvPr id="6" name="TextBox 5"/>
+          <p:cNvPr id="7" name="TextBox 6"/>
           <p:cNvSpPr txBox="1"/>
           <p:nvPr/>
         </p:nvSpPr>
@@ -4171,7 +4195,7 @@
                 </a:solidFill>
                 <a:latin typeface="Segoe UI"/>
               </a:rPr>
-              <a:t>Impacto de Kobra en la gestión</a:t>
+              <a:t>Cómo se mide el impacto de Kobra</a:t>
             </a:r>
           </a:p>
         </p:txBody>
@@ -4246,11 +4270,11 @@
             <a:r>
               <a:rPr sz="1500" b="0">
                 <a:solidFill>
-                  <a:srgbClr val="9AA4B2"/>
-                </a:solidFill>
-                <a:latin typeface="Segoe UI"/>
-              </a:rPr>
-              <a:t>Gestores que usan Kobra vs. grupo de control (mismo período)</a:t>
+                  <a:srgbClr val="FDCB6E"/>
+                </a:solidFill>
+                <a:latin typeface="Segoe UI"/>
+              </a:rPr>
+              <a:t>Metodología: gestores con Kobra vs. grupo de control, mismo período. Cifras ILUSTRATIVAS sobre datos sintéticos — no son resultados medidos.</a:t>
             </a:r>
           </a:p>
         </p:txBody>
@@ -4668,7 +4692,7 @@
                 </a:solidFill>
                 <a:latin typeface="Segoe UI"/>
               </a:rPr>
-              <a:t>Y la mejora se sostiene y crece mes a mes con la adopción de las herramientas.</a:t>
+              <a:t>En un piloto real, este mismo análisis (control vs. adopción) produce el impacto MEDIDO — esa es la evidencia que se presenta, no esta simulación.</a:t>
             </a:r>
           </a:p>
         </p:txBody>
@@ -5608,9 +5632,33 @@
         <p:nvPr/>
       </p:nvGrpSpPr>
       <p:grpSpPr/>
-      <p:sp>
-        <p:nvSpPr>
-          <p:cNvPr id="2" name="TextBox 1"/>
+      <p:pic>
+        <p:nvPicPr>
+          <p:cNvPr id="2" name="Picture 1" descr="kobra_icon.png"/>
+          <p:cNvPicPr>
+            <a:picLocks noChangeAspect="1"/>
+          </p:cNvPicPr>
+          <p:nvPr/>
+        </p:nvPicPr>
+        <p:blipFill>
+          <a:blip r:embed="rId2"/>
+          <a:stretch>
+            <a:fillRect/>
+          </a:stretch>
+        </p:blipFill>
+        <p:spPr>
+          <a:xfrm>
+            <a:off x="5641848" y="1051560"/>
+            <a:ext cx="914400" cy="914400"/>
+          </a:xfrm>
+          <a:prstGeom prst="rect">
+            <a:avLst/>
+          </a:prstGeom>
+        </p:spPr>
+      </p:pic>
+      <p:sp>
+        <p:nvSpPr>
+          <p:cNvPr id="3" name="TextBox 2"/>
           <p:cNvSpPr txBox="1"/>
           <p:nvPr/>
         </p:nvSpPr>
@@ -5645,7 +5693,7 @@
       </p:sp>
       <p:sp>
         <p:nvSpPr>
-          <p:cNvPr id="3" name="TextBox 2"/>
+          <p:cNvPr id="4" name="TextBox 3"/>
           <p:cNvSpPr txBox="1"/>
           <p:nvPr/>
         </p:nvSpPr>
@@ -5673,14 +5721,14 @@
                 </a:solidFill>
                 <a:latin typeface="Segoe UI"/>
               </a:rPr>
-              <a:t>🐍 Kobra · Cobranzas Inteligente</a:t>
-            </a:r>
-          </a:p>
-        </p:txBody>
-      </p:sp>
-      <p:sp>
-        <p:nvSpPr>
-          <p:cNvPr id="4" name="TextBox 3"/>
+              <a:t>Kobra · Cobranzas Inteligente</a:t>
+            </a:r>
+          </a:p>
+        </p:txBody>
+      </p:sp>
+      <p:sp>
+        <p:nvSpPr>
+          <p:cNvPr id="5" name="TextBox 4"/>
           <p:cNvSpPr txBox="1"/>
           <p:nvPr/>
         </p:nvSpPr>
@@ -6172,7 +6220,7 @@
                 </a:solidFill>
                 <a:latin typeface="Segoe UI"/>
               </a:rPr>
-              <a:t>Modelo de Machine Learning que estima la probabilidad de pago de cada deudor.</a:t>
+              <a:t>Modelo de Machine Learning que estima la probabilidad de pago de cada deudor. Selección de modelos con validación cruzada + calibración.</a:t>
             </a:r>
           </a:p>
         </p:txBody>
@@ -6207,7 +6255,7 @@
                 </a:solidFill>
                 <a:latin typeface="Segoe UI"/>
               </a:rPr>
-              <a:t>AUC 0.8705 · Lift 1.69x en el top decil</a:t>
+              <a:t>Se entrena y valida con la cartera real del cliente</a:t>
             </a:r>
           </a:p>
         </p:txBody>
@@ -8018,7 +8066,7 @@
                 </a:solidFill>
                 <a:latin typeface="Segoe UI"/>
               </a:rPr>
-              <a:t>Priorizando por ProbPago, el equipo concentra el esfuerzo donde está el valor recuperable.</a:t>
+              <a:t>Datos sintéticos ilustrativos: muestran cómo Kobra prioriza el esfuerzo donde está el valor recuperable. Con la cartera real, estos KPIs se calculan de verdad.</a:t>
             </a:r>
           </a:p>
         </p:txBody>

</xml_diff>

<commit_message>
Rebrand: Kobra IA · Cobranzas Inteligentes
Nuevo nombre comercial en todos los puntos de contacto: wordmark ("KOBRA IA"
con IA en verde de marca + "COBRANZAS INTELIGENTES"), dashboards (estático y
Streamlit), app realtime, PPT (portada/cierre), README, manual, paquetes
distribuibles (LEEME, licencias, VERSION, autorun) y docstrings de portada.
El ícono K-cobra se mantiene (aprobado). PPT y ZIPs regenerados; 18 tests OK.

Co-Authored-By: Claude Fable 5 <noreply@anthropic.com>
Claude-Session: https://claude.ai/code/session_01KGnVQvVgKrpMBAH6ciJfTu
</commit_message>
<xml_diff>
--- a/presentation/Kobra_Presentacion_Gerencial.pptx
+++ b/presentation/Kobra_Presentacion_Gerencial.pptx
@@ -3209,7 +3209,7 @@
                 </a:solidFill>
                 <a:latin typeface="Segoe UI"/>
               </a:rPr>
-              <a:t>Kobra</a:t>
+              <a:t>Kobra IA</a:t>
             </a:r>
           </a:p>
         </p:txBody>
@@ -3244,7 +3244,7 @@
                 </a:solidFill>
                 <a:latin typeface="Segoe UI"/>
               </a:rPr>
-              <a:t>Plataforma de Cobranzas Inteligente</a:t>
+              <a:t>Plataforma de Cobranzas Inteligentes</a:t>
             </a:r>
           </a:p>
         </p:txBody>
@@ -5721,7 +5721,7 @@
                 </a:solidFill>
                 <a:latin typeface="Segoe UI"/>
               </a:rPr>
-              <a:t>Kobra · Cobranzas Inteligente</a:t>
+              <a:t>Kobra IA · Cobranzas Inteligentes</a:t>
             </a:r>
           </a:p>
         </p:txBody>

</xml_diff>